<commit_message>
Student Academic Recommendation System
</commit_message>
<xml_diff>
--- a/Academic_Recommendation_Phase2.pptx
+++ b/Academic_Recommendation_Phase2.pptx
@@ -2290,7 +2290,7 @@
                 <a:ea typeface="Calibri" pitchFamily="34" charset="-122"/>
                 <a:cs typeface="Calibri" pitchFamily="34" charset="-120"/>
               </a:rPr>
-              <a:t>Phase 2: Web Development Evaluation</a:t>
+              <a:t>Phase 3: Web Development Evaluation</a:t>
             </a:r>
             <a:endParaRPr lang="en-US" sz="2000" dirty="0"/>
           </a:p>
@@ -3669,7 +3669,7 @@
                 <a:ea typeface="Calibri" pitchFamily="34" charset="-122"/>
                 <a:cs typeface="Calibri" pitchFamily="34" charset="-120"/>
               </a:rPr>
-              <a:t>Student Academic Recommendation System  |  Phase 2 Evaluation</a:t>
+              <a:t>Student Academic Recommendation System  |  Phase 3 Evaluation</a:t>
             </a:r>
             <a:endParaRPr lang="en-US" sz="900" dirty="0"/>
           </a:p>
@@ -4945,7 +4945,7 @@
                 <a:ea typeface="Calibri" pitchFamily="34" charset="-122"/>
                 <a:cs typeface="Calibri" pitchFamily="34" charset="-120"/>
               </a:rPr>
-              <a:t>Student Academic Recommendation System  |  Phase 2 Evaluation</a:t>
+              <a:t>Student Academic Recommendation System  |  Phase 3 Evaluation</a:t>
             </a:r>
             <a:endParaRPr lang="en-US" sz="900" dirty="0"/>
           </a:p>
@@ -5887,7 +5887,7 @@
                 <a:ea typeface="Calibri" pitchFamily="34" charset="-122"/>
                 <a:cs typeface="Calibri" pitchFamily="34" charset="-120"/>
               </a:rPr>
-              <a:t>Student Academic Recommendation System  |  Phase 2 Evaluation</a:t>
+              <a:t>Student Academic Recommendation System  |  Phase 3 Evaluation</a:t>
             </a:r>
             <a:endParaRPr lang="en-US" sz="900" dirty="0"/>
           </a:p>
@@ -7156,7 +7156,7 @@
                 <a:ea typeface="Calibri" pitchFamily="34" charset="-122"/>
                 <a:cs typeface="Calibri" pitchFamily="34" charset="-120"/>
               </a:rPr>
-              <a:t>Student Academic Recommendation System  |  Phase 2 Evaluation</a:t>
+              <a:t>Student Academic Recommendation System  |  Phase 3 Evaluation</a:t>
             </a:r>
             <a:endParaRPr lang="en-US" sz="900" dirty="0"/>
           </a:p>
@@ -8266,7 +8266,7 @@
                 <a:ea typeface="Calibri" pitchFamily="34" charset="-122"/>
                 <a:cs typeface="Calibri" pitchFamily="34" charset="-120"/>
               </a:rPr>
-              <a:t>Student Academic Recommendation System  |  Phase 2 Evaluation</a:t>
+              <a:t>Student Academic Recommendation System  |  Phase 3 Evaluation</a:t>
             </a:r>
             <a:endParaRPr lang="en-US" sz="900" dirty="0"/>
           </a:p>
@@ -9668,7 +9668,7 @@
                 <a:ea typeface="Calibri" pitchFamily="34" charset="-122"/>
                 <a:cs typeface="Calibri" pitchFamily="34" charset="-120"/>
               </a:rPr>
-              <a:t>Student Academic Recommendation System  |  Phase 2 Evaluation</a:t>
+              <a:t>Student Academic Recommendation System  |  Phase 3 Evaluation</a:t>
             </a:r>
             <a:endParaRPr lang="en-US" sz="900" dirty="0"/>
           </a:p>
@@ -10949,7 +10949,7 @@
                 <a:ea typeface="Calibri" pitchFamily="34" charset="-122"/>
                 <a:cs typeface="Calibri" pitchFamily="34" charset="-120"/>
               </a:rPr>
-              <a:t>Student Academic Recommendation System  |  Phase 2 Evaluation</a:t>
+              <a:t>Student Academic Recommendation System  |  Phase 3 Evaluation</a:t>
             </a:r>
             <a:endParaRPr lang="en-US" sz="900" dirty="0"/>
           </a:p>
@@ -12980,7 +12980,7 @@
                 <a:ea typeface="Calibri" pitchFamily="34" charset="-122"/>
                 <a:cs typeface="Calibri" pitchFamily="34" charset="-120"/>
               </a:rPr>
-              <a:t>Student Academic Recommendation System  |  Phase 2 Evaluation</a:t>
+              <a:t>Student Academic Recommendation System  |  Phase 3 Evaluation</a:t>
             </a:r>
             <a:endParaRPr lang="en-US" sz="900" dirty="0"/>
           </a:p>
@@ -14434,7 +14434,7 @@
                 <a:ea typeface="Calibri" pitchFamily="34" charset="-122"/>
                 <a:cs typeface="Calibri" pitchFamily="34" charset="-120"/>
               </a:rPr>
-              <a:t>Student Academic Recommendation System  |  Phase 2 Evaluation</a:t>
+              <a:t>Student Academic Recommendation System  |  Phase 3 Evaluation</a:t>
             </a:r>
             <a:endParaRPr lang="en-US" sz="900" dirty="0"/>
           </a:p>
@@ -15440,7 +15440,7 @@
                 <a:ea typeface="Calibri" pitchFamily="34" charset="-122"/>
                 <a:cs typeface="Calibri" pitchFamily="34" charset="-120"/>
               </a:rPr>
-              <a:t>Student Academic Recommendation System  |  Phase 2 Evaluation</a:t>
+              <a:t>Student Academic Recommendation System  |  Phase 3 Evaluation</a:t>
             </a:r>
             <a:endParaRPr lang="en-US" sz="900" dirty="0"/>
           </a:p>

</xml_diff>